<commit_message>
added the new bldg file fields
</commit_message>
<xml_diff>
--- a/figures/bldg_data_structure.pptx
+++ b/figures/bldg_data_structure.pptx
@@ -259,7 +259,7 @@
           <a:p>
             <a:fld id="{1A30122B-BC72-41F7-938E-33D4221D7AF9}" type="datetimeFigureOut">
               <a:rPr lang="en-US" smtClean="0"/>
-              <a:t>6/20/25</a:t>
+              <a:t>7/31/25</a:t>
             </a:fld>
             <a:endParaRPr lang="en-US"/>
           </a:p>
@@ -457,7 +457,7 @@
           <a:p>
             <a:fld id="{1A30122B-BC72-41F7-938E-33D4221D7AF9}" type="datetimeFigureOut">
               <a:rPr lang="en-US" smtClean="0"/>
-              <a:t>6/20/25</a:t>
+              <a:t>7/31/25</a:t>
             </a:fld>
             <a:endParaRPr lang="en-US"/>
           </a:p>
@@ -665,7 +665,7 @@
           <a:p>
             <a:fld id="{1A30122B-BC72-41F7-938E-33D4221D7AF9}" type="datetimeFigureOut">
               <a:rPr lang="en-US" smtClean="0"/>
-              <a:t>6/20/25</a:t>
+              <a:t>7/31/25</a:t>
             </a:fld>
             <a:endParaRPr lang="en-US"/>
           </a:p>
@@ -863,7 +863,7 @@
           <a:p>
             <a:fld id="{1A30122B-BC72-41F7-938E-33D4221D7AF9}" type="datetimeFigureOut">
               <a:rPr lang="en-US" smtClean="0"/>
-              <a:t>6/20/25</a:t>
+              <a:t>7/31/25</a:t>
             </a:fld>
             <a:endParaRPr lang="en-US"/>
           </a:p>
@@ -1138,7 +1138,7 @@
           <a:p>
             <a:fld id="{1A30122B-BC72-41F7-938E-33D4221D7AF9}" type="datetimeFigureOut">
               <a:rPr lang="en-US" smtClean="0"/>
-              <a:t>6/20/25</a:t>
+              <a:t>7/31/25</a:t>
             </a:fld>
             <a:endParaRPr lang="en-US"/>
           </a:p>
@@ -1403,7 +1403,7 @@
           <a:p>
             <a:fld id="{1A30122B-BC72-41F7-938E-33D4221D7AF9}" type="datetimeFigureOut">
               <a:rPr lang="en-US" smtClean="0"/>
-              <a:t>6/20/25</a:t>
+              <a:t>7/31/25</a:t>
             </a:fld>
             <a:endParaRPr lang="en-US"/>
           </a:p>
@@ -1815,7 +1815,7 @@
           <a:p>
             <a:fld id="{1A30122B-BC72-41F7-938E-33D4221D7AF9}" type="datetimeFigureOut">
               <a:rPr lang="en-US" smtClean="0"/>
-              <a:t>6/20/25</a:t>
+              <a:t>7/31/25</a:t>
             </a:fld>
             <a:endParaRPr lang="en-US"/>
           </a:p>
@@ -1956,7 +1956,7 @@
           <a:p>
             <a:fld id="{1A30122B-BC72-41F7-938E-33D4221D7AF9}" type="datetimeFigureOut">
               <a:rPr lang="en-US" smtClean="0"/>
-              <a:t>6/20/25</a:t>
+              <a:t>7/31/25</a:t>
             </a:fld>
             <a:endParaRPr lang="en-US"/>
           </a:p>
@@ -2069,7 +2069,7 @@
           <a:p>
             <a:fld id="{1A30122B-BC72-41F7-938E-33D4221D7AF9}" type="datetimeFigureOut">
               <a:rPr lang="en-US" smtClean="0"/>
-              <a:t>6/20/25</a:t>
+              <a:t>7/31/25</a:t>
             </a:fld>
             <a:endParaRPr lang="en-US"/>
           </a:p>
@@ -2380,7 +2380,7 @@
           <a:p>
             <a:fld id="{1A30122B-BC72-41F7-938E-33D4221D7AF9}" type="datetimeFigureOut">
               <a:rPr lang="en-US" smtClean="0"/>
-              <a:t>6/20/25</a:t>
+              <a:t>7/31/25</a:t>
             </a:fld>
             <a:endParaRPr lang="en-US"/>
           </a:p>
@@ -2668,7 +2668,7 @@
           <a:p>
             <a:fld id="{1A30122B-BC72-41F7-938E-33D4221D7AF9}" type="datetimeFigureOut">
               <a:rPr lang="en-US" smtClean="0"/>
-              <a:t>6/20/25</a:t>
+              <a:t>7/31/25</a:t>
             </a:fld>
             <a:endParaRPr lang="en-US"/>
           </a:p>
@@ -2909,7 +2909,7 @@
           <a:p>
             <a:fld id="{1A30122B-BC72-41F7-938E-33D4221D7AF9}" type="datetimeFigureOut">
               <a:rPr lang="en-US" smtClean="0"/>
-              <a:t>6/20/25</a:t>
+              <a:t>7/31/25</a:t>
             </a:fld>
             <a:endParaRPr lang="en-US"/>
           </a:p>
@@ -3437,7 +3437,7 @@
         <p:spPr>
           <a:xfrm>
             <a:off x="4965730" y="550187"/>
-            <a:ext cx="3352200" cy="1785104"/>
+            <a:ext cx="2523448" cy="2462213"/>
           </a:xfrm>
           <a:prstGeom prst="rect">
             <a:avLst/>
@@ -3528,7 +3528,7 @@
                 <a:ea typeface="Cascadia Mono Light" panose="020B0609020000020004" pitchFamily="49" charset="0"/>
                 <a:cs typeface="Cascadia Mono Light" panose="020B0609020000020004" pitchFamily="49" charset="0"/>
               </a:rPr>
-              <a:t>height_tower</a:t>
+              <a:t>height_parapet</a:t>
             </a:r>
             <a:r>
               <a:rPr lang="en-US" sz="1100" dirty="0">
@@ -3546,6 +3546,24 @@
                 <a:ea typeface="Cascadia Mono Light" panose="020B0609020000020004" pitchFamily="49" charset="0"/>
                 <a:cs typeface="Cascadia Mono Light" panose="020B0609020000020004" pitchFamily="49" charset="0"/>
               </a:rPr>
+              <a:t>height_tower</a:t>
+            </a:r>
+            <a:r>
+              <a:rPr lang="en-US" sz="1100" dirty="0">
+                <a:latin typeface="Cascadia Mono Light" panose="020B0609020000020004" pitchFamily="49" charset="0"/>
+                <a:ea typeface="Cascadia Mono Light" panose="020B0609020000020004" pitchFamily="49" charset="0"/>
+                <a:cs typeface="Cascadia Mono Light" panose="020B0609020000020004" pitchFamily="49" charset="0"/>
+              </a:rPr>
+              <a:t>: (optional)</a:t>
+            </a:r>
+          </a:p>
+          <a:p>
+            <a:r>
+              <a:rPr lang="en-US" sz="1100" dirty="0" err="1">
+                <a:latin typeface="Cascadia Mono Light" panose="020B0609020000020004" pitchFamily="49" charset="0"/>
+                <a:ea typeface="Cascadia Mono Light" panose="020B0609020000020004" pitchFamily="49" charset="0"/>
+                <a:cs typeface="Cascadia Mono Light" panose="020B0609020000020004" pitchFamily="49" charset="0"/>
+              </a:rPr>
               <a:t>roof_type</a:t>
             </a:r>
             <a:r>
@@ -3559,6 +3577,24 @@
           </a:p>
           <a:p>
             <a:r>
+              <a:rPr lang="en-US" sz="1100" dirty="0" err="1">
+                <a:latin typeface="Cascadia Mono Light" panose="020B0609020000020004" pitchFamily="49" charset="0"/>
+                <a:ea typeface="Cascadia Mono Light" panose="020B0609020000020004" pitchFamily="49" charset="0"/>
+                <a:cs typeface="Cascadia Mono Light" panose="020B0609020000020004" pitchFamily="49" charset="0"/>
+              </a:rPr>
+              <a:t>roof_pitch</a:t>
+            </a:r>
+            <a:r>
+              <a:rPr lang="en-US" sz="1100" dirty="0">
+                <a:latin typeface="Cascadia Mono Light" panose="020B0609020000020004" pitchFamily="49" charset="0"/>
+                <a:ea typeface="Cascadia Mono Light" panose="020B0609020000020004" pitchFamily="49" charset="0"/>
+                <a:cs typeface="Cascadia Mono Light" panose="020B0609020000020004" pitchFamily="49" charset="0"/>
+              </a:rPr>
+              <a:t>: (conditionally required)</a:t>
+            </a:r>
+          </a:p>
+          <a:p>
+            <a:r>
               <a:rPr lang="en-US" sz="1100" dirty="0">
                 <a:latin typeface="Cascadia Mono Light" panose="020B0609020000020004" pitchFamily="49" charset="0"/>
                 <a:ea typeface="Cascadia Mono Light" panose="020B0609020000020004" pitchFamily="49" charset="0"/>
@@ -3597,6 +3633,42 @@
           </a:p>
           <a:p>
             <a:r>
+              <a:rPr lang="en-US" sz="1100" dirty="0" err="1">
+                <a:latin typeface="Cascadia Mono Light" panose="020B0609020000020004" pitchFamily="49" charset="0"/>
+                <a:ea typeface="Cascadia Mono Light" panose="020B0609020000020004" pitchFamily="49" charset="0"/>
+                <a:cs typeface="Cascadia Mono Light" panose="020B0609020000020004" pitchFamily="49" charset="0"/>
+              </a:rPr>
+              <a:t>unit_separation</a:t>
+            </a:r>
+            <a:r>
+              <a:rPr lang="en-US" sz="1100" dirty="0">
+                <a:latin typeface="Cascadia Mono Light" panose="020B0609020000020004" pitchFamily="49" charset="0"/>
+                <a:ea typeface="Cascadia Mono Light" panose="020B0609020000020004" pitchFamily="49" charset="0"/>
+                <a:cs typeface="Cascadia Mono Light" panose="020B0609020000020004" pitchFamily="49" charset="0"/>
+              </a:rPr>
+              <a:t>: (conditionally required)</a:t>
+            </a:r>
+          </a:p>
+          <a:p>
+            <a:r>
+              <a:rPr lang="en-US" sz="1100" dirty="0" err="1">
+                <a:latin typeface="Cascadia Mono Light" panose="020B0609020000020004" pitchFamily="49" charset="0"/>
+                <a:ea typeface="Cascadia Mono Light" panose="020B0609020000020004" pitchFamily="49" charset="0"/>
+                <a:cs typeface="Cascadia Mono Light" panose="020B0609020000020004" pitchFamily="49" charset="0"/>
+              </a:rPr>
+              <a:t>sep_wall_length</a:t>
+            </a:r>
+            <a:r>
+              <a:rPr lang="en-US" sz="1100" dirty="0">
+                <a:latin typeface="Cascadia Mono Light" panose="020B0609020000020004" pitchFamily="49" charset="0"/>
+                <a:ea typeface="Cascadia Mono Light" panose="020B0609020000020004" pitchFamily="49" charset="0"/>
+                <a:cs typeface="Cascadia Mono Light" panose="020B0609020000020004" pitchFamily="49" charset="0"/>
+              </a:rPr>
+              <a:t>: (conditionally required)</a:t>
+            </a:r>
+          </a:p>
+          <a:p>
+            <a:r>
               <a:rPr lang="en-US" sz="1100" dirty="0">
                 <a:latin typeface="Cascadia Mono Light" panose="020B0609020000020004" pitchFamily="49" charset="0"/>
                 <a:ea typeface="Cascadia Mono Light" panose="020B0609020000020004" pitchFamily="49" charset="0"/>
@@ -3621,7 +3693,7 @@
         </p:nvSpPr>
         <p:spPr>
           <a:xfrm>
-            <a:off x="4005421" y="3610854"/>
+            <a:off x="4005421" y="4375378"/>
             <a:ext cx="934871" cy="261610"/>
           </a:xfrm>
           <a:prstGeom prst="rect">
@@ -3665,7 +3737,7 @@
         </p:nvSpPr>
         <p:spPr>
           <a:xfrm>
-            <a:off x="4965729" y="3798594"/>
+            <a:off x="4965729" y="4563118"/>
             <a:ext cx="601447" cy="261610"/>
           </a:xfrm>
           <a:prstGeom prst="rect">
@@ -3704,7 +3776,7 @@
         </p:nvSpPr>
         <p:spPr>
           <a:xfrm>
-            <a:off x="5989997" y="3954692"/>
+            <a:off x="5989997" y="4719216"/>
             <a:ext cx="2268570" cy="938719"/>
           </a:xfrm>
           <a:prstGeom prst="rect">
@@ -3809,7 +3881,7 @@
         </p:nvCxnSpPr>
         <p:spPr>
           <a:xfrm>
-            <a:off x="4237638" y="3845318"/>
+            <a:off x="4237638" y="4609842"/>
             <a:ext cx="728091" cy="84082"/>
           </a:xfrm>
           <a:prstGeom prst="bentConnector3">
@@ -3850,7 +3922,7 @@
         </p:nvSpPr>
         <p:spPr>
           <a:xfrm>
-            <a:off x="4983553" y="4883813"/>
+            <a:off x="4983553" y="5648337"/>
             <a:ext cx="601447" cy="261610"/>
           </a:xfrm>
           <a:prstGeom prst="rect">
@@ -3891,7 +3963,7 @@
         </p:nvCxnSpPr>
         <p:spPr>
           <a:xfrm>
-            <a:off x="4246877" y="4927822"/>
+            <a:off x="4246877" y="5692346"/>
             <a:ext cx="728091" cy="84082"/>
           </a:xfrm>
           <a:prstGeom prst="bentConnector3">
@@ -3934,7 +4006,7 @@
         </p:nvCxnSpPr>
         <p:spPr>
           <a:xfrm>
-            <a:off x="4234219" y="3919942"/>
+            <a:off x="4234219" y="4684466"/>
             <a:ext cx="0" cy="1007880"/>
           </a:xfrm>
           <a:prstGeom prst="line">
@@ -3975,12 +4047,12 @@
         </p:nvCxnSpPr>
         <p:spPr>
           <a:xfrm rot="16200000" flipH="1">
-            <a:off x="3788362" y="1013161"/>
-            <a:ext cx="1595321" cy="759414"/>
+            <a:off x="3460068" y="1378264"/>
+            <a:ext cx="2256516" cy="754806"/>
           </a:xfrm>
           <a:prstGeom prst="bentConnector3">
             <a:avLst>
-              <a:gd name="adj1" fmla="val 100012"/>
+              <a:gd name="adj1" fmla="val 99978"/>
             </a:avLst>
           </a:prstGeom>
           <a:ln>
@@ -4135,7 +4207,7 @@
         </p:nvCxnSpPr>
         <p:spPr>
           <a:xfrm>
-            <a:off x="5257040" y="4015055"/>
+            <a:off x="5257040" y="4779579"/>
             <a:ext cx="732958" cy="728288"/>
           </a:xfrm>
           <a:prstGeom prst="bentConnector3">
@@ -4178,7 +4250,7 @@
         </p:nvCxnSpPr>
         <p:spPr>
           <a:xfrm flipV="1">
-            <a:off x="5257040" y="4273771"/>
+            <a:off x="5257040" y="5038295"/>
             <a:ext cx="705258" cy="4098"/>
           </a:xfrm>
           <a:prstGeom prst="straightConnector1">
@@ -4219,7 +4291,7 @@
         </p:nvCxnSpPr>
         <p:spPr>
           <a:xfrm flipV="1">
-            <a:off x="5257039" y="4104615"/>
+            <a:off x="5257039" y="4869139"/>
             <a:ext cx="705258" cy="4098"/>
           </a:xfrm>
           <a:prstGeom prst="straightConnector1">
@@ -4258,7 +4330,7 @@
         </p:nvSpPr>
         <p:spPr>
           <a:xfrm>
-            <a:off x="3977433" y="2230376"/>
+            <a:off x="3977433" y="2994900"/>
             <a:ext cx="1018227" cy="261610"/>
           </a:xfrm>
           <a:prstGeom prst="rect">
@@ -4304,12 +4376,12 @@
         </p:nvCxnSpPr>
         <p:spPr>
           <a:xfrm rot="16200000" flipH="1">
-            <a:off x="1925464" y="1696010"/>
-            <a:ext cx="3355034" cy="748903"/>
+            <a:off x="1539303" y="2074374"/>
+            <a:ext cx="4119556" cy="756701"/>
           </a:xfrm>
           <a:prstGeom prst="bentConnector3">
             <a:avLst>
-              <a:gd name="adj1" fmla="val 99967"/>
+              <a:gd name="adj1" fmla="val 99982"/>
             </a:avLst>
           </a:prstGeom>
           <a:ln>
@@ -4388,7 +4460,7 @@
         </p:nvCxnSpPr>
         <p:spPr>
           <a:xfrm>
-            <a:off x="3225337" y="2373451"/>
+            <a:off x="3225337" y="3137975"/>
             <a:ext cx="783320" cy="0"/>
           </a:xfrm>
           <a:prstGeom prst="straightConnector1">
@@ -4429,7 +4501,7 @@
         </p:nvCxnSpPr>
         <p:spPr>
           <a:xfrm>
-            <a:off x="5274979" y="2699586"/>
+            <a:off x="5274979" y="3464110"/>
             <a:ext cx="754806" cy="276898"/>
           </a:xfrm>
           <a:prstGeom prst="bentConnector3">
@@ -4470,7 +4542,7 @@
         </p:nvSpPr>
         <p:spPr>
           <a:xfrm>
-            <a:off x="6013049" y="2650190"/>
+            <a:off x="6013049" y="3414714"/>
             <a:ext cx="2268570" cy="430887"/>
           </a:xfrm>
           <a:prstGeom prst="rect">
@@ -4529,7 +4601,7 @@
         </p:nvCxnSpPr>
         <p:spPr>
           <a:xfrm>
-            <a:off x="5271023" y="2796174"/>
+            <a:off x="5271023" y="3560698"/>
             <a:ext cx="760740" cy="0"/>
           </a:xfrm>
           <a:prstGeom prst="straightConnector1">
@@ -4568,7 +4640,7 @@
         </p:nvSpPr>
         <p:spPr>
           <a:xfrm>
-            <a:off x="4975042" y="2437659"/>
+            <a:off x="4975042" y="3202183"/>
             <a:ext cx="601447" cy="261610"/>
           </a:xfrm>
           <a:prstGeom prst="rect">
@@ -4609,7 +4681,7 @@
         </p:nvCxnSpPr>
         <p:spPr>
           <a:xfrm>
-            <a:off x="4246951" y="2484382"/>
+            <a:off x="4246951" y="3248906"/>
             <a:ext cx="728091" cy="84082"/>
           </a:xfrm>
           <a:prstGeom prst="bentConnector3">
@@ -4650,7 +4722,7 @@
         </p:nvSpPr>
         <p:spPr>
           <a:xfrm>
-            <a:off x="5004354" y="3061669"/>
+            <a:off x="5004354" y="3826193"/>
             <a:ext cx="601447" cy="261610"/>
           </a:xfrm>
           <a:prstGeom prst="rect">
@@ -4691,7 +4763,7 @@
         </p:nvCxnSpPr>
         <p:spPr>
           <a:xfrm>
-            <a:off x="4249353" y="3127340"/>
+            <a:off x="4249353" y="3891864"/>
             <a:ext cx="728091" cy="84082"/>
           </a:xfrm>
           <a:prstGeom prst="bentConnector3">
@@ -4734,7 +4806,7 @@
         </p:nvCxnSpPr>
         <p:spPr>
           <a:xfrm>
-            <a:off x="4237806" y="2568464"/>
+            <a:off x="4237806" y="3332988"/>
             <a:ext cx="0" cy="579275"/>
           </a:xfrm>
           <a:prstGeom prst="line">
@@ -4775,7 +4847,7 @@
         </p:nvCxnSpPr>
         <p:spPr>
           <a:xfrm>
-            <a:off x="5271023" y="3344814"/>
+            <a:off x="5271023" y="4109338"/>
             <a:ext cx="754806" cy="276898"/>
           </a:xfrm>
           <a:prstGeom prst="bentConnector3">
@@ -4816,7 +4888,7 @@
         </p:nvSpPr>
         <p:spPr>
           <a:xfrm>
-            <a:off x="6029785" y="3297637"/>
+            <a:off x="6029785" y="4062161"/>
             <a:ext cx="2268570" cy="430887"/>
           </a:xfrm>
           <a:prstGeom prst="rect">
@@ -4875,7 +4947,7 @@
         </p:nvCxnSpPr>
         <p:spPr>
           <a:xfrm>
-            <a:off x="5267067" y="3441402"/>
+            <a:off x="5267067" y="4205926"/>
             <a:ext cx="760740" cy="0"/>
           </a:xfrm>
           <a:prstGeom prst="straightConnector1">
@@ -5072,7 +5144,7 @@
         </p:nvCxnSpPr>
         <p:spPr>
           <a:xfrm flipV="1">
-            <a:off x="5232480" y="4438139"/>
+            <a:off x="5232480" y="5202663"/>
             <a:ext cx="705258" cy="4098"/>
           </a:xfrm>
           <a:prstGeom prst="straightConnector1">
@@ -5113,7 +5185,7 @@
         </p:nvCxnSpPr>
         <p:spPr>
           <a:xfrm flipV="1">
-            <a:off x="5257039" y="4595520"/>
+            <a:off x="5257039" y="5360044"/>
             <a:ext cx="705258" cy="4098"/>
           </a:xfrm>
           <a:prstGeom prst="straightConnector1">
@@ -5152,7 +5224,7 @@
         </p:nvSpPr>
         <p:spPr>
           <a:xfrm>
-            <a:off x="5989997" y="5119616"/>
+            <a:off x="5989997" y="5884140"/>
             <a:ext cx="2268570" cy="938719"/>
           </a:xfrm>
           <a:prstGeom prst="rect">
@@ -5257,7 +5329,7 @@
         </p:nvCxnSpPr>
         <p:spPr>
           <a:xfrm>
-            <a:off x="5257040" y="5179979"/>
+            <a:off x="5257040" y="5944503"/>
             <a:ext cx="732958" cy="728288"/>
           </a:xfrm>
           <a:prstGeom prst="bentConnector3">
@@ -5300,7 +5372,7 @@
         </p:nvCxnSpPr>
         <p:spPr>
           <a:xfrm flipV="1">
-            <a:off x="5257040" y="5438695"/>
+            <a:off x="5257040" y="6203219"/>
             <a:ext cx="705258" cy="4098"/>
           </a:xfrm>
           <a:prstGeom prst="straightConnector1">
@@ -5341,7 +5413,7 @@
         </p:nvCxnSpPr>
         <p:spPr>
           <a:xfrm flipV="1">
-            <a:off x="5257039" y="5269539"/>
+            <a:off x="5257039" y="6034063"/>
             <a:ext cx="705258" cy="4098"/>
           </a:xfrm>
           <a:prstGeom prst="straightConnector1">
@@ -5382,7 +5454,7 @@
         </p:nvCxnSpPr>
         <p:spPr>
           <a:xfrm flipV="1">
-            <a:off x="5232480" y="5603063"/>
+            <a:off x="5232480" y="6367587"/>
             <a:ext cx="705258" cy="4098"/>
           </a:xfrm>
           <a:prstGeom prst="straightConnector1">
@@ -5423,7 +5495,7 @@
         </p:nvCxnSpPr>
         <p:spPr>
           <a:xfrm flipV="1">
-            <a:off x="5257039" y="5760444"/>
+            <a:off x="5257039" y="6524968"/>
             <a:ext cx="705258" cy="4098"/>
           </a:xfrm>
           <a:prstGeom prst="straightConnector1">
@@ -5502,6 +5574,162 @@
         <p:spPr>
           <a:xfrm>
             <a:off x="4210923" y="2016435"/>
+            <a:ext cx="754806" cy="0"/>
+          </a:xfrm>
+          <a:prstGeom prst="straightConnector1">
+            <a:avLst/>
+          </a:prstGeom>
+          <a:ln>
+            <a:tailEnd type="triangle"/>
+          </a:ln>
+        </p:spPr>
+        <p:style>
+          <a:lnRef idx="2">
+            <a:schemeClr val="dk1"/>
+          </a:lnRef>
+          <a:fillRef idx="0">
+            <a:schemeClr val="dk1"/>
+          </a:fillRef>
+          <a:effectRef idx="1">
+            <a:schemeClr val="dk1"/>
+          </a:effectRef>
+          <a:fontRef idx="minor">
+            <a:schemeClr val="tx1"/>
+          </a:fontRef>
+        </p:style>
+      </p:cxnSp>
+      <p:cxnSp>
+        <p:nvCxnSpPr>
+          <p:cNvPr id="7" name="Straight Arrow Connector 6">
+            <a:extLst>
+              <a:ext uri="{FF2B5EF4-FFF2-40B4-BE49-F238E27FC236}">
+                <a16:creationId xmlns:a16="http://schemas.microsoft.com/office/drawing/2014/main" id="{319E762C-0333-F3DD-B6C7-810FF876BAA5}"/>
+              </a:ext>
+            </a:extLst>
+          </p:cNvPr>
+          <p:cNvCxnSpPr/>
+          <p:nvPr/>
+        </p:nvCxnSpPr>
+        <p:spPr>
+          <a:xfrm>
+            <a:off x="4210923" y="2184600"/>
+            <a:ext cx="754806" cy="0"/>
+          </a:xfrm>
+          <a:prstGeom prst="straightConnector1">
+            <a:avLst/>
+          </a:prstGeom>
+          <a:ln>
+            <a:tailEnd type="triangle"/>
+          </a:ln>
+        </p:spPr>
+        <p:style>
+          <a:lnRef idx="2">
+            <a:schemeClr val="dk1"/>
+          </a:lnRef>
+          <a:fillRef idx="0">
+            <a:schemeClr val="dk1"/>
+          </a:fillRef>
+          <a:effectRef idx="1">
+            <a:schemeClr val="dk1"/>
+          </a:effectRef>
+          <a:fontRef idx="minor">
+            <a:schemeClr val="tx1"/>
+          </a:fontRef>
+        </p:style>
+      </p:cxnSp>
+      <p:cxnSp>
+        <p:nvCxnSpPr>
+          <p:cNvPr id="8" name="Straight Arrow Connector 7">
+            <a:extLst>
+              <a:ext uri="{FF2B5EF4-FFF2-40B4-BE49-F238E27FC236}">
+                <a16:creationId xmlns:a16="http://schemas.microsoft.com/office/drawing/2014/main" id="{CAFCD99D-1ABB-4875-570D-2FA5EEA70567}"/>
+              </a:ext>
+            </a:extLst>
+          </p:cNvPr>
+          <p:cNvCxnSpPr/>
+          <p:nvPr/>
+        </p:nvCxnSpPr>
+        <p:spPr>
+          <a:xfrm>
+            <a:off x="4210923" y="2363276"/>
+            <a:ext cx="754806" cy="0"/>
+          </a:xfrm>
+          <a:prstGeom prst="straightConnector1">
+            <a:avLst/>
+          </a:prstGeom>
+          <a:ln>
+            <a:tailEnd type="triangle"/>
+          </a:ln>
+        </p:spPr>
+        <p:style>
+          <a:lnRef idx="2">
+            <a:schemeClr val="dk1"/>
+          </a:lnRef>
+          <a:fillRef idx="0">
+            <a:schemeClr val="dk1"/>
+          </a:fillRef>
+          <a:effectRef idx="1">
+            <a:schemeClr val="dk1"/>
+          </a:effectRef>
+          <a:fontRef idx="minor">
+            <a:schemeClr val="tx1"/>
+          </a:fontRef>
+        </p:style>
+      </p:cxnSp>
+      <p:cxnSp>
+        <p:nvCxnSpPr>
+          <p:cNvPr id="9" name="Straight Arrow Connector 8">
+            <a:extLst>
+              <a:ext uri="{FF2B5EF4-FFF2-40B4-BE49-F238E27FC236}">
+                <a16:creationId xmlns:a16="http://schemas.microsoft.com/office/drawing/2014/main" id="{7B1ED39C-B385-7584-AE17-88B3F7AB9987}"/>
+              </a:ext>
+            </a:extLst>
+          </p:cNvPr>
+          <p:cNvCxnSpPr/>
+          <p:nvPr/>
+        </p:nvCxnSpPr>
+        <p:spPr>
+          <a:xfrm>
+            <a:off x="4210923" y="2541951"/>
+            <a:ext cx="754806" cy="0"/>
+          </a:xfrm>
+          <a:prstGeom prst="straightConnector1">
+            <a:avLst/>
+          </a:prstGeom>
+          <a:ln>
+            <a:tailEnd type="triangle"/>
+          </a:ln>
+        </p:spPr>
+        <p:style>
+          <a:lnRef idx="2">
+            <a:schemeClr val="dk1"/>
+          </a:lnRef>
+          <a:fillRef idx="0">
+            <a:schemeClr val="dk1"/>
+          </a:fillRef>
+          <a:effectRef idx="1">
+            <a:schemeClr val="dk1"/>
+          </a:effectRef>
+          <a:fontRef idx="minor">
+            <a:schemeClr val="tx1"/>
+          </a:fontRef>
+        </p:style>
+      </p:cxnSp>
+      <p:cxnSp>
+        <p:nvCxnSpPr>
+          <p:cNvPr id="24" name="Straight Arrow Connector 23">
+            <a:extLst>
+              <a:ext uri="{FF2B5EF4-FFF2-40B4-BE49-F238E27FC236}">
+                <a16:creationId xmlns:a16="http://schemas.microsoft.com/office/drawing/2014/main" id="{5CBE39E4-4955-A737-DC35-B4C0EB128A06}"/>
+              </a:ext>
+            </a:extLst>
+          </p:cNvPr>
+          <p:cNvCxnSpPr/>
+          <p:nvPr/>
+        </p:nvCxnSpPr>
+        <p:spPr>
+          <a:xfrm>
+            <a:off x="4210923" y="2710117"/>
             <a:ext cx="754806" cy="0"/>
           </a:xfrm>
           <a:prstGeom prst="straightConnector1">

</xml_diff>